<commit_message>
Polish How Brands Grow lecture: fuller layouts on three slides
Co-Authored-By: Claude Opus 5.5 <noreply@anthropic.com>
</commit_message>
<xml_diff>
--- a/slides/how-brands-grow_double-jeopardy-and-distinctiveness_WT26-27.pptx
+++ b/slides/how-brands-grow_double-jeopardy-and-distinctiveness_WT26-27.pptx
@@ -27483,6 +27483,29 @@
               <a:t>Free download (check licence)</a:t>
             </a:r>
           </a:p>
+          <a:p>
+            <a:pPr algn="l">
+              <a:spcAft>
+                <a:spcPts val="700"/>
+              </a:spcAft>
+            </a:pPr>
+            <a:r>
+              <a:rPr lang="en-GB" sz="1200" b="1" i="0">
+                <a:solidFill>
+                  <a:schemeClr val="tx1"/>
+                </a:solidFill>
+              </a:rPr>
+              <a:t>Alternatives: </a:t>
+            </a:r>
+            <a:r>
+              <a:rPr lang="en-GB" sz="1200" b="0" i="0">
+                <a:solidFill>
+                  <a:schemeClr val="tx1"/>
+                </a:solidFill>
+              </a:rPr>
+              <a:t>MovieLens 32M, Instacart (Kaggle)</a:t>
+            </a:r>
+          </a:p>
         </p:txBody>
       </p:sp>
       <p:sp>
@@ -32548,7 +32571,7 @@
         <p:spPr>
           <a:xfrm>
             <a:off x="457200" y="1280160"/>
-            <a:ext cx="4032504" cy="2148840"/>
+            <a:ext cx="4032504" cy="2468880"/>
           </a:xfrm>
           <a:prstGeom prst="rect">
             <a:avLst/>
@@ -32699,7 +32722,7 @@
         <p:spPr>
           <a:xfrm>
             <a:off x="594360" y="1847088"/>
-            <a:ext cx="3758184" cy="1490472"/>
+            <a:ext cx="3758184" cy="1810512"/>
           </a:xfrm>
           <a:prstGeom prst="rect">
             <a:avLst/>
@@ -32718,7 +32741,7 @@
               </a:spcAft>
             </a:pPr>
             <a:r>
-              <a:rPr lang="en-GB" sz="1300" b="1" i="0">
+              <a:rPr lang="en-GB" sz="1400" b="1" i="0">
                 <a:solidFill>
                   <a:schemeClr val="tx1"/>
                 </a:solidFill>
@@ -32726,7 +32749,7 @@
               <a:t>Colour: </a:t>
             </a:r>
             <a:r>
-              <a:rPr lang="en-GB" sz="1300" b="0" i="0">
+              <a:rPr lang="en-GB" sz="1400" b="0" i="0">
                 <a:solidFill>
                   <a:schemeClr val="tx1"/>
                 </a:solidFill>
@@ -32741,7 +32764,7 @@
               </a:spcAft>
             </a:pPr>
             <a:r>
-              <a:rPr lang="en-GB" sz="1300" b="1" i="0">
+              <a:rPr lang="en-GB" sz="1400" b="1" i="0">
                 <a:solidFill>
                   <a:schemeClr val="tx1"/>
                 </a:solidFill>
@@ -32749,7 +32772,7 @@
               <a:t>Symbol: </a:t>
             </a:r>
             <a:r>
-              <a:rPr lang="en-GB" sz="1300" b="0" i="0">
+              <a:rPr lang="en-GB" sz="1400" b="0" i="0">
                 <a:solidFill>
                   <a:schemeClr val="tx1"/>
                 </a:solidFill>
@@ -32764,7 +32787,7 @@
               </a:spcAft>
             </a:pPr>
             <a:r>
-              <a:rPr lang="en-GB" sz="1300" b="1" i="0">
+              <a:rPr lang="en-GB" sz="1400" b="1" i="0">
                 <a:solidFill>
                   <a:schemeClr val="tx1"/>
                 </a:solidFill>
@@ -32772,7 +32795,7 @@
               <a:t>Product: </a:t>
             </a:r>
             <a:r>
-              <a:rPr lang="en-GB" sz="1300" b="0" i="0">
+              <a:rPr lang="en-GB" sz="1400" b="0" i="0">
                 <a:solidFill>
                   <a:schemeClr val="tx1"/>
                 </a:solidFill>
@@ -32787,7 +32810,7 @@
               </a:spcAft>
             </a:pPr>
             <a:r>
-              <a:rPr lang="en-GB" sz="1300" b="1" i="0">
+              <a:rPr lang="en-GB" sz="1400" b="1" i="0">
                 <a:solidFill>
                   <a:schemeClr val="tx1"/>
                 </a:solidFill>
@@ -32795,7 +32818,7 @@
               <a:t>Slogan: </a:t>
             </a:r>
             <a:r>
-              <a:rPr lang="en-GB" sz="1300" b="0" i="0">
+              <a:rPr lang="en-GB" sz="1400" b="0" i="0">
                 <a:solidFill>
                   <a:schemeClr val="tx1"/>
                 </a:solidFill>
@@ -32814,7 +32837,7 @@
         <p:spPr>
           <a:xfrm>
             <a:off x="4654296" y="1280160"/>
-            <a:ext cx="4032504" cy="2148840"/>
+            <a:ext cx="4032504" cy="2468880"/>
           </a:xfrm>
           <a:prstGeom prst="rect">
             <a:avLst/>
@@ -32965,7 +32988,7 @@
         <p:spPr>
           <a:xfrm>
             <a:off x="4791456" y="1847088"/>
-            <a:ext cx="3758184" cy="1490472"/>
+            <a:ext cx="3758184" cy="1810512"/>
           </a:xfrm>
           <a:prstGeom prst="rect">
             <a:avLst/>
@@ -32984,7 +33007,7 @@
               </a:spcAft>
             </a:pPr>
             <a:r>
-              <a:rPr lang="en-GB" sz="1300" b="1" i="0">
+              <a:rPr lang="en-GB" sz="1400" b="1" i="0">
                 <a:solidFill>
                   <a:schemeClr val="tx1"/>
                 </a:solidFill>
@@ -32992,7 +33015,7 @@
               <a:t>Heritage: </a:t>
             </a:r>
             <a:r>
-              <a:rPr lang="en-GB" sz="1300" b="0" i="0">
+              <a:rPr lang="en-GB" sz="1400" b="0" i="0">
                 <a:solidFill>
                   <a:schemeClr val="tx1"/>
                 </a:solidFill>
@@ -33007,7 +33030,7 @@
               </a:spcAft>
             </a:pPr>
             <a:r>
-              <a:rPr lang="en-GB" sz="1300" b="1" i="0">
+              <a:rPr lang="en-GB" sz="1400" b="1" i="0">
                 <a:solidFill>
                   <a:schemeClr val="tx1"/>
                 </a:solidFill>
@@ -33015,7 +33038,7 @@
               <a:t>Associations: </a:t>
             </a:r>
             <a:r>
-              <a:rPr lang="en-GB" sz="1300" b="0" i="0">
+              <a:rPr lang="en-GB" sz="1400" b="0" i="0">
                 <a:solidFill>
                   <a:schemeClr val="tx1"/>
                 </a:solidFill>
@@ -33030,7 +33053,7 @@
               </a:spcAft>
             </a:pPr>
             <a:r>
-              <a:rPr lang="en-GB" sz="1300" b="1" i="0">
+              <a:rPr lang="en-GB" sz="1400" b="1" i="0">
                 <a:solidFill>
                   <a:schemeClr val="tx1"/>
                 </a:solidFill>
@@ -33038,7 +33061,7 @@
               <a:t>Feelings: </a:t>
             </a:r>
             <a:r>
-              <a:rPr lang="en-GB" sz="1300" b="0" i="0">
+              <a:rPr lang="en-GB" sz="1400" b="0" i="0">
                 <a:solidFill>
                   <a:schemeClr val="tx1"/>
                 </a:solidFill>
@@ -33056,7 +33079,7 @@
         </p:nvSpPr>
         <p:spPr>
           <a:xfrm>
-            <a:off x="457200" y="3611880"/>
+            <a:off x="457200" y="3977639"/>
             <a:ext cx="8229600" cy="502920"/>
           </a:xfrm>
           <a:prstGeom prst="rect">
@@ -33100,7 +33123,7 @@
         </p:nvSpPr>
         <p:spPr>
           <a:xfrm>
-            <a:off x="640080" y="3611880"/>
+            <a:off x="640080" y="3977639"/>
             <a:ext cx="7863840" cy="502920"/>
           </a:xfrm>
           <a:prstGeom prst="rect">
@@ -33233,7 +33256,7 @@
         <p:spPr>
           <a:xfrm>
             <a:off x="457200" y="1234440"/>
-            <a:ext cx="4032504" cy="1097280"/>
+            <a:ext cx="4032504" cy="1234440"/>
           </a:xfrm>
           <a:prstGeom prst="rect">
             <a:avLst/>
@@ -33384,7 +33407,7 @@
         <p:spPr>
           <a:xfrm>
             <a:off x="594360" y="1801368"/>
-            <a:ext cx="3758184" cy="438912"/>
+            <a:ext cx="3758184" cy="576072"/>
           </a:xfrm>
           <a:prstGeom prst="rect">
             <a:avLst/>
@@ -33403,7 +33426,7 @@
               </a:spcAft>
             </a:pPr>
             <a:r>
-              <a:rPr lang="en-GB" sz="1200" b="1" i="0">
+              <a:rPr lang="en-GB" sz="1300" b="1" i="0">
                 <a:solidFill>
                   <a:schemeClr val="tx1"/>
                 </a:solidFill>
@@ -33411,7 +33434,7 @@
               <a:t>Identify </a:t>
             </a:r>
             <a:r>
-              <a:rPr lang="en-GB" sz="1200" b="0" i="0">
+              <a:rPr lang="en-GB" sz="1300" b="0" i="0">
                 <a:solidFill>
                   <a:schemeClr val="tx1"/>
                 </a:solidFill>
@@ -33419,7 +33442,7 @@
               <a:t>the maker quickly; </a:t>
             </a:r>
             <a:r>
-              <a:rPr lang="en-GB" sz="1200" b="1" i="0">
+              <a:rPr lang="en-GB" sz="1300" b="1" i="0">
                 <a:solidFill>
                   <a:schemeClr val="tx1"/>
                 </a:solidFill>
@@ -33427,7 +33450,7 @@
               <a:t>cut search </a:t>
             </a:r>
             <a:r>
-              <a:rPr lang="en-GB" sz="1200" b="0" i="0">
+              <a:rPr lang="en-GB" sz="1300" b="0" i="0">
                 <a:solidFill>
                   <a:schemeClr val="tx1"/>
                 </a:solidFill>
@@ -33435,7 +33458,7 @@
               <a:t>time and </a:t>
             </a:r>
             <a:r>
-              <a:rPr lang="en-GB" sz="1200" b="1" i="0">
+              <a:rPr lang="en-GB" sz="1300" b="1" i="0">
                 <a:solidFill>
                   <a:schemeClr val="tx1"/>
                 </a:solidFill>
@@ -33454,7 +33477,7 @@
         <p:spPr>
           <a:xfrm>
             <a:off x="4654296" y="1234440"/>
-            <a:ext cx="4032504" cy="1097280"/>
+            <a:ext cx="4032504" cy="1234440"/>
           </a:xfrm>
           <a:prstGeom prst="rect">
             <a:avLst/>
@@ -33605,7 +33628,7 @@
         <p:spPr>
           <a:xfrm>
             <a:off x="4791456" y="1801368"/>
-            <a:ext cx="3758184" cy="438912"/>
+            <a:ext cx="3758184" cy="576072"/>
           </a:xfrm>
           <a:prstGeom prst="rect">
             <a:avLst/>
@@ -33624,7 +33647,7 @@
               </a:spcAft>
             </a:pPr>
             <a:r>
-              <a:rPr lang="en-GB" sz="1200" b="1" i="0">
+              <a:rPr lang="en-GB" sz="1300" b="1" i="0">
                 <a:solidFill>
                   <a:schemeClr val="tx1"/>
                 </a:solidFill>
@@ -33632,7 +33655,7 @@
               <a:t>Legal protection, </a:t>
             </a:r>
             <a:r>
-              <a:rPr lang="en-GB" sz="1200" b="0" i="0">
+              <a:rPr lang="en-GB" sz="1300" b="0" i="0">
                 <a:solidFill>
                   <a:schemeClr val="tx1"/>
                 </a:solidFill>
@@ -33640,7 +33663,7 @@
               <a:t>price premium, easier launches and </a:t>
             </a:r>
             <a:r>
-              <a:rPr lang="en-GB" sz="1200" b="1" i="0">
+              <a:rPr lang="en-GB" sz="1300" b="1" i="0">
                 <a:solidFill>
                   <a:schemeClr val="tx1"/>
                 </a:solidFill>
@@ -33658,7 +33681,7 @@
         </p:nvSpPr>
         <p:spPr>
           <a:xfrm>
-            <a:off x="457200" y="2560320"/>
+            <a:off x="457200" y="2697480"/>
             <a:ext cx="2139696" cy="457200"/>
           </a:xfrm>
           <a:prstGeom prst="homePlate">
@@ -33710,7 +33733,7 @@
         </p:nvSpPr>
         <p:spPr>
           <a:xfrm>
-            <a:off x="2487168" y="2560320"/>
+            <a:off x="2487168" y="2697480"/>
             <a:ext cx="2139696" cy="457200"/>
           </a:xfrm>
           <a:prstGeom prst="chevron">
@@ -33762,7 +33785,7 @@
         </p:nvSpPr>
         <p:spPr>
           <a:xfrm>
-            <a:off x="4517136" y="2560320"/>
+            <a:off x="4517136" y="2697480"/>
             <a:ext cx="2139696" cy="457200"/>
           </a:xfrm>
           <a:prstGeom prst="chevron">
@@ -33814,7 +33837,7 @@
         </p:nvSpPr>
         <p:spPr>
           <a:xfrm>
-            <a:off x="6547103" y="2560320"/>
+            <a:off x="6547103" y="2697480"/>
             <a:ext cx="2139696" cy="457200"/>
           </a:xfrm>
           <a:prstGeom prst="chevron">
@@ -33860,14 +33883,58 @@
       </p:sp>
       <p:sp>
         <p:nvSpPr>
-          <p:cNvPr id="20" name="Brand step 1"/>
+          <p:cNvPr id="20" name="Brand step box 1"/>
+          <p:cNvSpPr/>
+          <p:nvPr/>
+        </p:nvSpPr>
+        <p:spPr>
+          <a:xfrm>
+            <a:off x="502920" y="3246120"/>
+            <a:ext cx="1938527" cy="685800"/>
+          </a:xfrm>
+          <a:prstGeom prst="rect">
+            <a:avLst/>
+          </a:prstGeom>
+          <a:solidFill>
+            <a:schemeClr val="bg2"/>
+          </a:solidFill>
+          <a:ln>
+            <a:noFill/>
+          </a:ln>
+          <a:effectLst/>
+        </p:spPr>
+        <p:style>
+          <a:lnRef idx="1">
+            <a:schemeClr val="accent1"/>
+          </a:lnRef>
+          <a:fillRef idx="3">
+            <a:schemeClr val="accent1"/>
+          </a:fillRef>
+          <a:effectRef idx="2">
+            <a:schemeClr val="accent1"/>
+          </a:effectRef>
+          <a:fontRef idx="minor">
+            <a:schemeClr val="lt1"/>
+          </a:fontRef>
+        </p:style>
+        <p:txBody>
+          <a:bodyPr rtlCol="0" anchor="ctr"/>
+          <a:lstStyle/>
+          <a:p>
+            <a:pPr algn="ctr"/>
+          </a:p>
+        </p:txBody>
+      </p:sp>
+      <p:sp>
+        <p:nvSpPr>
+          <p:cNvPr id="21" name="Brand step 1"/>
           <p:cNvSpPr txBox="1"/>
           <p:nvPr/>
         </p:nvSpPr>
         <p:spPr>
           <a:xfrm>
-            <a:off x="548640" y="3108960"/>
-            <a:ext cx="1865376" cy="502920"/>
+            <a:off x="594360" y="3246120"/>
+            <a:ext cx="1755648" cy="685800"/>
           </a:xfrm>
           <a:prstGeom prst="rect">
             <a:avLst/>
@@ -33875,7 +33942,7 @@
           <a:noFill/>
         </p:spPr>
         <p:txBody>
-          <a:bodyPr wrap="square" lIns="36576" rIns="36576" tIns="18288" bIns="18288" anchor="t">
+          <a:bodyPr wrap="square" lIns="36576" rIns="36576" tIns="18288" bIns="18288" anchor="ctr">
             <a:spAutoFit/>
           </a:bodyPr>
           <a:lstStyle/>
@@ -33886,7 +33953,7 @@
               </a:spcAft>
             </a:pPr>
             <a:r>
-              <a:rPr lang="en-GB" sz="1150" b="0" i="0">
+              <a:rPr lang="en-GB" sz="1200" b="0" i="0">
                 <a:solidFill>
                   <a:schemeClr val="tx1"/>
                 </a:solidFill>
@@ -33898,14 +33965,58 @@
       </p:sp>
       <p:sp>
         <p:nvSpPr>
-          <p:cNvPr id="21" name="Brand step 2"/>
+          <p:cNvPr id="22" name="Brand step box 2"/>
+          <p:cNvSpPr/>
+          <p:nvPr/>
+        </p:nvSpPr>
+        <p:spPr>
+          <a:xfrm>
+            <a:off x="2532887" y="3246120"/>
+            <a:ext cx="1938527" cy="685800"/>
+          </a:xfrm>
+          <a:prstGeom prst="rect">
+            <a:avLst/>
+          </a:prstGeom>
+          <a:solidFill>
+            <a:schemeClr val="bg2"/>
+          </a:solidFill>
+          <a:ln>
+            <a:noFill/>
+          </a:ln>
+          <a:effectLst/>
+        </p:spPr>
+        <p:style>
+          <a:lnRef idx="1">
+            <a:schemeClr val="accent1"/>
+          </a:lnRef>
+          <a:fillRef idx="3">
+            <a:schemeClr val="accent1"/>
+          </a:fillRef>
+          <a:effectRef idx="2">
+            <a:schemeClr val="accent1"/>
+          </a:effectRef>
+          <a:fontRef idx="minor">
+            <a:schemeClr val="lt1"/>
+          </a:fontRef>
+        </p:style>
+        <p:txBody>
+          <a:bodyPr rtlCol="0" anchor="ctr"/>
+          <a:lstStyle/>
+          <a:p>
+            <a:pPr algn="ctr"/>
+          </a:p>
+        </p:txBody>
+      </p:sp>
+      <p:sp>
+        <p:nvSpPr>
+          <p:cNvPr id="23" name="Brand step 2"/>
           <p:cNvSpPr txBox="1"/>
           <p:nvPr/>
         </p:nvSpPr>
         <p:spPr>
           <a:xfrm>
-            <a:off x="2578608" y="3108960"/>
-            <a:ext cx="1865376" cy="502920"/>
+            <a:off x="2624327" y="3246120"/>
+            <a:ext cx="1755648" cy="685800"/>
           </a:xfrm>
           <a:prstGeom prst="rect">
             <a:avLst/>
@@ -33913,7 +34024,7 @@
           <a:noFill/>
         </p:spPr>
         <p:txBody>
-          <a:bodyPr wrap="square" lIns="36576" rIns="36576" tIns="18288" bIns="18288" anchor="t">
+          <a:bodyPr wrap="square" lIns="36576" rIns="36576" tIns="18288" bIns="18288" anchor="ctr">
             <a:spAutoFit/>
           </a:bodyPr>
           <a:lstStyle/>
@@ -33924,7 +34035,7 @@
               </a:spcAft>
             </a:pPr>
             <a:r>
-              <a:rPr lang="en-GB" sz="1150" b="0" i="0">
+              <a:rPr lang="en-GB" sz="1200" b="0" i="0">
                 <a:solidFill>
                   <a:schemeClr val="tx1"/>
                 </a:solidFill>
@@ -33936,14 +34047,58 @@
       </p:sp>
       <p:sp>
         <p:nvSpPr>
-          <p:cNvPr id="22" name="Brand step 3"/>
+          <p:cNvPr id="24" name="Brand step box 3"/>
+          <p:cNvSpPr/>
+          <p:nvPr/>
+        </p:nvSpPr>
+        <p:spPr>
+          <a:xfrm>
+            <a:off x="4562855" y="3246120"/>
+            <a:ext cx="1938527" cy="685800"/>
+          </a:xfrm>
+          <a:prstGeom prst="rect">
+            <a:avLst/>
+          </a:prstGeom>
+          <a:solidFill>
+            <a:schemeClr val="bg2"/>
+          </a:solidFill>
+          <a:ln>
+            <a:noFill/>
+          </a:ln>
+          <a:effectLst/>
+        </p:spPr>
+        <p:style>
+          <a:lnRef idx="1">
+            <a:schemeClr val="accent1"/>
+          </a:lnRef>
+          <a:fillRef idx="3">
+            <a:schemeClr val="accent1"/>
+          </a:fillRef>
+          <a:effectRef idx="2">
+            <a:schemeClr val="accent1"/>
+          </a:effectRef>
+          <a:fontRef idx="minor">
+            <a:schemeClr val="lt1"/>
+          </a:fontRef>
+        </p:style>
+        <p:txBody>
+          <a:bodyPr rtlCol="0" anchor="ctr"/>
+          <a:lstStyle/>
+          <a:p>
+            <a:pPr algn="ctr"/>
+          </a:p>
+        </p:txBody>
+      </p:sp>
+      <p:sp>
+        <p:nvSpPr>
+          <p:cNvPr id="25" name="Brand step 3"/>
           <p:cNvSpPr txBox="1"/>
           <p:nvPr/>
         </p:nvSpPr>
         <p:spPr>
           <a:xfrm>
-            <a:off x="4608575" y="3108960"/>
-            <a:ext cx="1865376" cy="502920"/>
+            <a:off x="4654296" y="3246120"/>
+            <a:ext cx="1755648" cy="685800"/>
           </a:xfrm>
           <a:prstGeom prst="rect">
             <a:avLst/>
@@ -33951,7 +34106,7 @@
           <a:noFill/>
         </p:spPr>
         <p:txBody>
-          <a:bodyPr wrap="square" lIns="36576" rIns="36576" tIns="18288" bIns="18288" anchor="t">
+          <a:bodyPr wrap="square" lIns="36576" rIns="36576" tIns="18288" bIns="18288" anchor="ctr">
             <a:spAutoFit/>
           </a:bodyPr>
           <a:lstStyle/>
@@ -33962,7 +34117,7 @@
               </a:spcAft>
             </a:pPr>
             <a:r>
-              <a:rPr lang="en-GB" sz="1150" b="0" i="0">
+              <a:rPr lang="en-GB" sz="1200" b="0" i="0">
                 <a:solidFill>
                   <a:schemeClr val="tx1"/>
                 </a:solidFill>
@@ -33974,14 +34129,58 @@
       </p:sp>
       <p:sp>
         <p:nvSpPr>
-          <p:cNvPr id="23" name="Brand step 4"/>
+          <p:cNvPr id="26" name="Brand step box 4"/>
+          <p:cNvSpPr/>
+          <p:nvPr/>
+        </p:nvSpPr>
+        <p:spPr>
+          <a:xfrm>
+            <a:off x="6592823" y="3246120"/>
+            <a:ext cx="1938527" cy="685800"/>
+          </a:xfrm>
+          <a:prstGeom prst="rect">
+            <a:avLst/>
+          </a:prstGeom>
+          <a:solidFill>
+            <a:schemeClr val="bg2"/>
+          </a:solidFill>
+          <a:ln>
+            <a:noFill/>
+          </a:ln>
+          <a:effectLst/>
+        </p:spPr>
+        <p:style>
+          <a:lnRef idx="1">
+            <a:schemeClr val="accent1"/>
+          </a:lnRef>
+          <a:fillRef idx="3">
+            <a:schemeClr val="accent1"/>
+          </a:fillRef>
+          <a:effectRef idx="2">
+            <a:schemeClr val="accent1"/>
+          </a:effectRef>
+          <a:fontRef idx="minor">
+            <a:schemeClr val="lt1"/>
+          </a:fontRef>
+        </p:style>
+        <p:txBody>
+          <a:bodyPr rtlCol="0" anchor="ctr"/>
+          <a:lstStyle/>
+          <a:p>
+            <a:pPr algn="ctr"/>
+          </a:p>
+        </p:txBody>
+      </p:sp>
+      <p:sp>
+        <p:nvSpPr>
+          <p:cNvPr id="27" name="Brand step 4"/>
           <p:cNvSpPr txBox="1"/>
           <p:nvPr/>
         </p:nvSpPr>
         <p:spPr>
           <a:xfrm>
-            <a:off x="6638543" y="3108960"/>
-            <a:ext cx="1865376" cy="502920"/>
+            <a:off x="6684264" y="3246120"/>
+            <a:ext cx="1755648" cy="685800"/>
           </a:xfrm>
           <a:prstGeom prst="rect">
             <a:avLst/>
@@ -33989,7 +34188,7 @@
           <a:noFill/>
         </p:spPr>
         <p:txBody>
-          <a:bodyPr wrap="square" lIns="36576" rIns="36576" tIns="18288" bIns="18288" anchor="t">
+          <a:bodyPr wrap="square" lIns="36576" rIns="36576" tIns="18288" bIns="18288" anchor="ctr">
             <a:spAutoFit/>
           </a:bodyPr>
           <a:lstStyle/>
@@ -34000,7 +34199,7 @@
               </a:spcAft>
             </a:pPr>
             <a:r>
-              <a:rPr lang="en-GB" sz="1150" b="0" i="0">
+              <a:rPr lang="en-GB" sz="1200" b="0" i="0">
                 <a:solidFill>
                   <a:schemeClr val="tx1"/>
                 </a:solidFill>
@@ -34012,13 +34211,13 @@
       </p:sp>
       <p:sp>
         <p:nvSpPr>
-          <p:cNvPr id="24" name="Bridge to Ehrenberg-Bass"/>
+          <p:cNvPr id="28" name="Bridge to Ehrenberg-Bass"/>
           <p:cNvSpPr/>
           <p:nvPr/>
         </p:nvSpPr>
         <p:spPr>
           <a:xfrm>
-            <a:off x="457200" y="3794760"/>
+            <a:off x="457200" y="4114800"/>
             <a:ext cx="8229600" cy="457200"/>
           </a:xfrm>
           <a:prstGeom prst="rect">
@@ -34056,13 +34255,13 @@
       </p:sp>
       <p:sp>
         <p:nvSpPr>
-          <p:cNvPr id="25" name="Bridge to Ehrenberg-Bass text"/>
+          <p:cNvPr id="29" name="Bridge to Ehrenberg-Bass text"/>
           <p:cNvSpPr txBox="1"/>
           <p:nvPr/>
         </p:nvSpPr>
         <p:spPr>
           <a:xfrm>
-            <a:off x="640080" y="3794760"/>
+            <a:off x="640080" y="4114800"/>
             <a:ext cx="7863840" cy="457200"/>
           </a:xfrm>
           <a:prstGeom prst="rect">
@@ -34096,6 +34295,44 @@
                 </a:solidFill>
               </a:rPr>
               <a:t>which of these activities actually make brands grow?</a:t>
+            </a:r>
+          </a:p>
+        </p:txBody>
+      </p:sp>
+      <p:sp>
+        <p:nvSpPr>
+          <p:cNvPr id="30" name="Source note"/>
+          <p:cNvSpPr txBox="1"/>
+          <p:nvPr/>
+        </p:nvSpPr>
+        <p:spPr>
+          <a:xfrm>
+            <a:off x="457200" y="4663440"/>
+            <a:ext cx="8229600" cy="320040"/>
+          </a:xfrm>
+          <a:prstGeom prst="rect">
+            <a:avLst/>
+          </a:prstGeom>
+          <a:noFill/>
+        </p:spPr>
+        <p:txBody>
+          <a:bodyPr wrap="square" lIns="36576" rIns="36576" tIns="18288" bIns="18288" anchor="t">
+            <a:spAutoFit/>
+          </a:bodyPr>
+          <a:lstStyle/>
+          <a:p>
+            <a:pPr algn="l">
+              <a:spcAft>
+                <a:spcPts val="0"/>
+              </a:spcAft>
+            </a:pPr>
+            <a:r>
+              <a:rPr lang="en-GB" sz="1050" b="0" i="0">
+                <a:solidFill>
+                  <a:srgbClr val="595959"/>
+                </a:solidFill>
+              </a:rPr>
+              <a:t>Keller &amp; Swaminathan (2020) Strategic Brand Management, ch. 1-2; Keller (1993) Journal of Marketing.</a:t>
             </a:r>
           </a:p>
         </p:txBody>

</xml_diff>